<commit_message>
Remove fixed branding from business template layouts
</commit_message>
<xml_diff>
--- a/templates/business-template.pptx
+++ b/templates/business-template.pptx
@@ -753,99 +753,6 @@
           </a:p>
         </p:txBody>
       </p:sp>
-      <p:pic>
-        <p:nvPicPr>
-          <p:cNvPr id="12" name="Picture 11">
-            <a:extLst>
-              <a:ext uri="{FF2B5EF4-FFF2-40B4-BE49-F238E27FC236}">
-                <a16:creationId xmlns:a16="http://schemas.microsoft.com/office/drawing/2014/main" id="{E3C572CF-2988-8D0A-D593-67BDD1EE1E56}"/>
-              </a:ext>
-            </a:extLst>
-          </p:cNvPr>
-          <p:cNvPicPr>
-            <a:picLocks noChangeAspect="1"/>
-          </p:cNvPicPr>
-          <p:nvPr userDrawn="1"/>
-        </p:nvPicPr>
-        <p:blipFill>
-          <a:blip r:embed="rId2"/>
-          <a:stretch>
-            <a:fillRect/>
-          </a:stretch>
-        </p:blipFill>
-        <p:spPr>
-          <a:xfrm>
-            <a:off x="536536" y="6681334"/>
-            <a:ext cx="487910" cy="487910"/>
-          </a:xfrm>
-          <a:prstGeom prst="rect">
-            <a:avLst/>
-          </a:prstGeom>
-        </p:spPr>
-      </p:pic>
-      <p:sp>
-        <p:nvSpPr>
-          <p:cNvPr id="5" name="Company Branding">
-            <a:extLst>
-              <a:ext uri="{FF2B5EF4-FFF2-40B4-BE49-F238E27FC236}">
-                <a16:creationId xmlns:a16="http://schemas.microsoft.com/office/drawing/2014/main" id="{F2866C24-D237-9B31-7F7D-8868151E1D15}"/>
-              </a:ext>
-            </a:extLst>
-          </p:cNvPr>
-          <p:cNvSpPr txBox="1">
-            <a:spLocks/>
-          </p:cNvSpPr>
-          <p:nvPr userDrawn="1"/>
-        </p:nvSpPr>
-        <p:spPr>
-          <a:xfrm>
-            <a:off x="1219356" y="6681334"/>
-            <a:ext cx="4529978" cy="481230"/>
-          </a:xfrm>
-          <a:prstGeom prst="rect">
-            <a:avLst/>
-          </a:prstGeom>
-        </p:spPr>
-        <p:txBody>
-          <a:bodyPr vert="horz" lIns="72000" tIns="72000" rIns="72000" bIns="72000" rtlCol="0" anchor="ctr" anchorCtr="0">
-            <a:noAutofit/>
-          </a:bodyPr>
-          <a:lstStyle>
-            <a:lvl1pPr algn="l" defTabSz="1007943" rtl="0" eaLnBrk="1" latinLnBrk="0" hangingPunct="1">
-              <a:lnSpc>
-                <a:spcPct val="90000"/>
-              </a:lnSpc>
-              <a:spcBef>
-                <a:spcPct val="0"/>
-              </a:spcBef>
-              <a:buNone/>
-              <a:defRPr sz="4850" kern="1200">
-                <a:solidFill>
-                  <a:schemeClr val="tx1"/>
-                </a:solidFill>
-                <a:latin typeface="Futura Medium" panose="020B0602020204020303" pitchFamily="34" charset="-79"/>
-                <a:ea typeface="+mj-ea"/>
-                <a:cs typeface="Futura Medium" panose="020B0602020204020303" pitchFamily="34" charset="-79"/>
-              </a:defRPr>
-            </a:lvl1pPr>
-          </a:lstStyle>
-          <a:p>
-            <a:r>
-              <a:rPr lang="en-US" sz="1800" b="0" i="0" dirty="0">
-                <a:solidFill>
-                  <a:schemeClr val="tx1">
-                    <a:lumMod val="50000"/>
-                    <a:lumOff val="50000"/>
-                  </a:schemeClr>
-                </a:solidFill>
-                <a:latin typeface="Arial" panose="020B0604020202020204" pitchFamily="34" charset="0"/>
-                <a:cs typeface="Arial" panose="020B0604020202020204" pitchFamily="34" charset="0"/>
-              </a:rPr>
-              <a:t>My Consulting Company</a:t>
-            </a:r>
-          </a:p>
-        </p:txBody>
-      </p:sp>
       <p:sp>
         <p:nvSpPr>
           <p:cNvPr id="2" name="title">
@@ -1216,52 +1123,6 @@
               <a:t>Click to edit Master subtitle style</a:t>
             </a:r>
             <a:endParaRPr lang="en-US" dirty="0"/>
-          </a:p>
-        </p:txBody>
-      </p:sp>
-      <p:sp>
-        <p:nvSpPr>
-          <p:cNvPr id="24" name="TextBox 23">
-            <a:extLst>
-              <a:ext uri="{FF2B5EF4-FFF2-40B4-BE49-F238E27FC236}">
-                <a16:creationId xmlns:a16="http://schemas.microsoft.com/office/drawing/2014/main" id="{8DB4EF47-F609-FB0A-8616-6963B89CD874}"/>
-              </a:ext>
-            </a:extLst>
-          </p:cNvPr>
-          <p:cNvSpPr txBox="1"/>
-          <p:nvPr userDrawn="1"/>
-        </p:nvSpPr>
-        <p:spPr>
-          <a:xfrm>
-            <a:off x="9388063" y="6937099"/>
-            <a:ext cx="3051672" cy="439032"/>
-          </a:xfrm>
-          <a:prstGeom prst="rect">
-            <a:avLst/>
-          </a:prstGeom>
-        </p:spPr>
-        <p:txBody>
-          <a:bodyPr vert="horz" lIns="72000" tIns="72000" rIns="36000" bIns="72000" rtlCol="0" anchor="ctr"/>
-          <a:lstStyle>
-            <a:defPPr>
-              <a:defRPr lang="en-US"/>
-            </a:defPPr>
-            <a:lvl1pPr algn="ctr">
-              <a:defRPr sz="1000">
-                <a:latin typeface="Futura Medium" panose="020B0602020204020303" pitchFamily="34" charset="-79"/>
-                <a:cs typeface="Futura Medium" panose="020B0602020204020303" pitchFamily="34" charset="-79"/>
-              </a:defRPr>
-            </a:lvl1pPr>
-          </a:lstStyle>
-          <a:p>
-            <a:pPr lvl="0" algn="r"/>
-            <a:r>
-              <a:rPr lang="en-US" b="0" i="0" dirty="0">
-                <a:latin typeface="Arial" panose="020B0604020202020204" pitchFamily="34" charset="0"/>
-                <a:cs typeface="Arial" panose="020B0604020202020204" pitchFamily="34" charset="0"/>
-              </a:rPr>
-              <a:t>My Consulting Company</a:t>
-            </a:r>
           </a:p>
         </p:txBody>
       </p:sp>

</xml_diff>

<commit_message>
fix(template): remove banding from business title background
</commit_message>
<xml_diff>
--- a/templates/business-template.pptx
+++ b/templates/business-template.pptx
@@ -1298,32 +1298,12 @@
   <p:cSld name="Title Slide">
     <p:bg>
       <p:bgPr>
-        <a:gradFill>
-          <a:gsLst>
-            <a:gs pos="0">
-              <a:schemeClr val="accent1">
-                <a:lumMod val="5000"/>
-                <a:lumOff val="95000"/>
-              </a:schemeClr>
-            </a:gs>
-            <a:gs pos="74000">
-              <a:schemeClr val="bg2">
-                <a:lumMod val="46000"/>
-                <a:lumOff val="54000"/>
-              </a:schemeClr>
-            </a:gs>
-            <a:gs pos="83000">
-              <a:schemeClr val="bg2">
-                <a:lumMod val="57000"/>
-                <a:lumOff val="43000"/>
-              </a:schemeClr>
-            </a:gs>
-            <a:gs pos="100000">
-              <a:schemeClr val="bg2"/>
-            </a:gs>
-          </a:gsLst>
-          <a:lin ang="5400000" scaled="1"/>
-        </a:gradFill>
+        <a:solidFill>
+          <a:schemeClr val="accent1">
+            <a:lumMod val="5000"/>
+            <a:lumOff val="95000"/>
+          </a:schemeClr>
+        </a:solidFill>
         <a:effectLst/>
       </p:bgPr>
     </p:bg>

</xml_diff>

<commit_message>
fix(template): improve business native body leading
</commit_message>
<xml_diff>
--- a/templates/business-template.pptx
+++ b/templates/business-template.pptx
@@ -1570,9 +1570,15 @@
           </a:bodyPr>
           <a:lstStyle>
             <a:lvl1pPr>
+              <a:lnSpc>
+                <a:spcPct val="110000"/>
+              </a:lnSpc>
               <a:defRPr sz="1800"/>
             </a:lvl1pPr>
             <a:lvl2pPr>
+              <a:lnSpc>
+                <a:spcPct val="110000"/>
+              </a:lnSpc>
               <a:defRPr sz="1600"/>
             </a:lvl2pPr>
           </a:lstStyle>
@@ -1617,9 +1623,15 @@
           </a:bodyPr>
           <a:lstStyle>
             <a:lvl1pPr>
+              <a:lnSpc>
+                <a:spcPct val="110000"/>
+              </a:lnSpc>
               <a:defRPr sz="1800"/>
             </a:lvl1pPr>
             <a:lvl2pPr>
+              <a:lnSpc>
+                <a:spcPct val="110000"/>
+              </a:lnSpc>
               <a:defRPr sz="1600"/>
             </a:lvl2pPr>
           </a:lstStyle>

</xml_diff>